<commit_message>
feat: agrega contenido a diapositiva Entrada-Procesos-Salidas
</commit_message>
<xml_diff>
--- a/presentacion/presentar_el_proyecto/Formato para presentar el Proyecto 2025.pptx
+++ b/presentacion/presentar_el_proyecto/Formato para presentar el Proyecto 2025.pptx
@@ -4617,6 +4617,87 @@
             <a:pPr algn="ctr"/>
             <a:endParaRPr lang="es-VE"/>
           </a:p>
+          <a:p>
+            <a:pPr>
+              <a:spcAft>
+                <a:spcPts val="800"/>
+              </a:spcAft>
+              <a:defRPr sz="1400" b="1">
+                <a:solidFill>
+                  <a:srgbClr val="000000"/>
+                </a:solidFill>
+              </a:defRPr>
+            </a:pPr>
+            <a:r>
+              <a:t>PROCESOS</a:t>
+            </a:r>
+          </a:p>
+          <a:p>
+            <a:pPr>
+              <a:spcAft>
+                <a:spcPts val="400"/>
+              </a:spcAft>
+              <a:defRPr sz="1100"/>
+            </a:pPr>
+            <a:r>
+              <a:t>• Control de inventario (entradas, salidas, ajustes)</a:t>
+            </a:r>
+          </a:p>
+          <a:p>
+            <a:pPr>
+              <a:spcAft>
+                <a:spcPts val="400"/>
+              </a:spcAft>
+              <a:defRPr sz="1100"/>
+            </a:pPr>
+            <a:r>
+              <a:t>• Gestión de ventas (totales, pagos mixtos VES/USD)</a:t>
+            </a:r>
+          </a:p>
+          <a:p>
+            <a:pPr>
+              <a:spcAft>
+                <a:spcPts val="400"/>
+              </a:spcAft>
+              <a:defRPr sz="1100"/>
+            </a:pPr>
+            <a:r>
+              <a:t>• Autenticación con bcrypt</a:t>
+            </a:r>
+          </a:p>
+          <a:p>
+            <a:pPr>
+              <a:spcAft>
+                <a:spcPts val="400"/>
+              </a:spcAft>
+              <a:defRPr sz="1100"/>
+            </a:pPr>
+            <a:r>
+              <a:t>• Generación de reportes diarios</a:t>
+            </a:r>
+          </a:p>
+          <a:p>
+            <a:pPr>
+              <a:spcAft>
+                <a:spcPts val="400"/>
+              </a:spcAft>
+              <a:defRPr sz="1100"/>
+            </a:pPr>
+            <a:r>
+              <a:t>• Consulta automática de tasas BCV</a:t>
+            </a:r>
+          </a:p>
+          <a:p>
+            <a:pPr>
+              <a:spcAft>
+                <a:spcPts val="400"/>
+              </a:spcAft>
+              <a:defRPr sz="1100"/>
+            </a:pPr>
+            <a:r>
+              <a:t>• Alertas de stock bajo</a:t>
+            </a:r>
+          </a:p>
         </p:txBody>
       </p:sp>
       <p:sp>
@@ -4648,6 +4729,61 @@
             </a:r>
             <a:endParaRPr lang="es-VE" sz="2400" b="1" dirty="0"/>
           </a:p>
+          <a:p>
+            <a:pPr>
+              <a:spcAft>
+                <a:spcPts val="400"/>
+              </a:spcAft>
+              <a:defRPr sz="1100"/>
+            </a:pPr>
+            <a:r>
+              <a:t>• Facturas detalladas de venta</a:t>
+            </a:r>
+          </a:p>
+          <a:p>
+            <a:pPr>
+              <a:spcAft>
+                <a:spcPts val="400"/>
+              </a:spcAft>
+              <a:defRPr sz="1100"/>
+            </a:pPr>
+            <a:r>
+              <a:t>• Reportes diarios exportables a Excel</a:t>
+            </a:r>
+          </a:p>
+          <a:p>
+            <a:pPr>
+              <a:spcAft>
+                <a:spcPts val="400"/>
+              </a:spcAft>
+              <a:defRPr sz="1100"/>
+            </a:pPr>
+            <a:r>
+              <a:t>• Dashboard con resumen de ventas y stock</a:t>
+            </a:r>
+          </a:p>
+          <a:p>
+            <a:pPr>
+              <a:spcAft>
+                <a:spcPts val="400"/>
+              </a:spcAft>
+              <a:defRPr sz="1100"/>
+            </a:pPr>
+            <a:r>
+              <a:t>• Alertas visuales de inventario</a:t>
+            </a:r>
+          </a:p>
+          <a:p>
+            <a:pPr>
+              <a:spcAft>
+                <a:spcPts val="400"/>
+              </a:spcAft>
+              <a:defRPr sz="1100"/>
+            </a:pPr>
+            <a:r>
+              <a:t>• Historial de movimientos y ventas</a:t>
+            </a:r>
+          </a:p>
         </p:txBody>
       </p:sp>
       <p:sp>
@@ -4678,6 +4814,50 @@
               <a:t>ENTRADAS</a:t>
             </a:r>
             <a:endParaRPr lang="es-VE" sz="2400" b="1" dirty="0"/>
+          </a:p>
+          <a:p>
+            <a:pPr>
+              <a:spcAft>
+                <a:spcPts val="400"/>
+              </a:spcAft>
+              <a:defRPr sz="1100"/>
+            </a:pPr>
+            <a:r>
+              <a:t>• Datos de productos (nombre, categoría, precio, stock)</a:t>
+            </a:r>
+          </a:p>
+          <a:p>
+            <a:pPr>
+              <a:spcAft>
+                <a:spcPts val="400"/>
+              </a:spcAft>
+              <a:defRPr sz="1100"/>
+            </a:pPr>
+            <a:r>
+              <a:t>• Registro de ventas (productos, cantidades, pagos)</a:t>
+            </a:r>
+          </a:p>
+          <a:p>
+            <a:pPr>
+              <a:spcAft>
+                <a:spcPts val="400"/>
+              </a:spcAft>
+              <a:defRPr sz="1100"/>
+            </a:pPr>
+            <a:r>
+              <a:t>• Credenciales de usuarios</a:t>
+            </a:r>
+          </a:p>
+          <a:p>
+            <a:pPr>
+              <a:spcAft>
+                <a:spcPts val="400"/>
+              </a:spcAft>
+              <a:defRPr sz="1100"/>
+            </a:pPr>
+            <a:r>
+              <a:t>• Tasas de cambio desde BCV</a:t>
+            </a:r>
           </a:p>
         </p:txBody>
       </p:sp>

</xml_diff>

<commit_message>
fix: corrige posicion de contenido en Entrada-Procesos-Salidas
</commit_message>
<xml_diff>
--- a/presentacion/presentar_el_proyecto/Formato para presentar el Proyecto 2025.pptx
+++ b/presentacion/presentar_el_proyecto/Formato para presentar el Proyecto 2025.pptx
@@ -4737,7 +4737,7 @@
               <a:defRPr sz="1100"/>
             </a:pPr>
             <a:r>
-              <a:t>• Facturas detalladas de venta</a:t>
+              <a:t/>
             </a:r>
           </a:p>
           <a:p>
@@ -4748,7 +4748,7 @@
               <a:defRPr sz="1100"/>
             </a:pPr>
             <a:r>
-              <a:t>• Reportes diarios exportables a Excel</a:t>
+              <a:t/>
             </a:r>
           </a:p>
           <a:p>
@@ -4759,7 +4759,7 @@
               <a:defRPr sz="1100"/>
             </a:pPr>
             <a:r>
-              <a:t>• Dashboard con resumen de ventas y stock</a:t>
+              <a:t/>
             </a:r>
           </a:p>
           <a:p>
@@ -4770,7 +4770,7 @@
               <a:defRPr sz="1100"/>
             </a:pPr>
             <a:r>
-              <a:t>• Alertas visuales de inventario</a:t>
+              <a:t/>
             </a:r>
           </a:p>
           <a:p>
@@ -4781,7 +4781,7 @@
               <a:defRPr sz="1100"/>
             </a:pPr>
             <a:r>
-              <a:t>• Historial de movimientos y ventas</a:t>
+              <a:t/>
             </a:r>
           </a:p>
         </p:txBody>
@@ -4823,7 +4823,7 @@
               <a:defRPr sz="1100"/>
             </a:pPr>
             <a:r>
-              <a:t>• Datos de productos (nombre, categoría, precio, stock)</a:t>
+              <a:t/>
             </a:r>
           </a:p>
           <a:p>
@@ -4834,7 +4834,7 @@
               <a:defRPr sz="1100"/>
             </a:pPr>
             <a:r>
-              <a:t>• Registro de ventas (productos, cantidades, pagos)</a:t>
+              <a:t/>
             </a:r>
           </a:p>
           <a:p>
@@ -4845,7 +4845,7 @@
               <a:defRPr sz="1100"/>
             </a:pPr>
             <a:r>
-              <a:t>• Credenciales de usuarios</a:t>
+              <a:t/>
             </a:r>
           </a:p>
           <a:p>
@@ -4856,7 +4856,7 @@
               <a:defRPr sz="1100"/>
             </a:pPr>
             <a:r>
-              <a:t>• Tasas de cambio desde BCV</a:t>
+              <a:t/>
             </a:r>
           </a:p>
         </p:txBody>
@@ -4972,6 +4972,151 @@
           </a:fontRef>
         </p:style>
       </p:cxnSp>
+      <p:sp>
+        <p:nvSpPr>
+          <p:cNvPr id="12" name="TextBox 11"/>
+          <p:cNvSpPr txBox="1"/>
+          <p:nvPr/>
+        </p:nvSpPr>
+        <p:spPr>
+          <a:xfrm>
+            <a:off x="600000" y="2500000"/>
+            <a:ext cx="3200000" cy="1800000"/>
+          </a:xfrm>
+          <a:prstGeom prst="rect">
+            <a:avLst/>
+          </a:prstGeom>
+          <a:noFill/>
+        </p:spPr>
+        <p:txBody>
+          <a:bodyPr wrap="square">
+            <a:spAutoFit/>
+          </a:bodyPr>
+          <a:lstStyle/>
+          <a:p>
+            <a:pPr>
+              <a:spcAft>
+                <a:spcPts val="400"/>
+              </a:spcAft>
+              <a:defRPr sz="1100"/>
+            </a:pPr>
+            <a:r>
+              <a:t>• Datos de productos (nombre, categoría, precio, stock)</a:t>
+            </a:r>
+          </a:p>
+          <a:p>
+            <a:pPr>
+              <a:spcAft>
+                <a:spcPts val="400"/>
+              </a:spcAft>
+              <a:defRPr sz="1100"/>
+            </a:pPr>
+            <a:r>
+              <a:t>• Registro de ventas (productos, cantidades, pagos)</a:t>
+            </a:r>
+          </a:p>
+          <a:p>
+            <a:pPr>
+              <a:spcAft>
+                <a:spcPts val="400"/>
+              </a:spcAft>
+              <a:defRPr sz="1100"/>
+            </a:pPr>
+            <a:r>
+              <a:t>• Credenciales de usuarios</a:t>
+            </a:r>
+          </a:p>
+          <a:p>
+            <a:pPr>
+              <a:spcAft>
+                <a:spcPts val="400"/>
+              </a:spcAft>
+              <a:defRPr sz="1100"/>
+            </a:pPr>
+            <a:r>
+              <a:t>• Tasas de cambio desde BCV</a:t>
+            </a:r>
+          </a:p>
+        </p:txBody>
+      </p:sp>
+      <p:sp>
+        <p:nvSpPr>
+          <p:cNvPr id="13" name="TextBox 12"/>
+          <p:cNvSpPr txBox="1"/>
+          <p:nvPr/>
+        </p:nvSpPr>
+        <p:spPr>
+          <a:xfrm>
+            <a:off x="7900000" y="2500000"/>
+            <a:ext cx="3600000" cy="2000000"/>
+          </a:xfrm>
+          <a:prstGeom prst="rect">
+            <a:avLst/>
+          </a:prstGeom>
+          <a:noFill/>
+        </p:spPr>
+        <p:txBody>
+          <a:bodyPr wrap="square">
+            <a:spAutoFit/>
+          </a:bodyPr>
+          <a:lstStyle/>
+          <a:p>
+            <a:pPr>
+              <a:spcAft>
+                <a:spcPts val="400"/>
+              </a:spcAft>
+              <a:defRPr sz="1100"/>
+            </a:pPr>
+            <a:r>
+              <a:t>• Facturas detalladas de venta</a:t>
+            </a:r>
+          </a:p>
+          <a:p>
+            <a:pPr>
+              <a:spcAft>
+                <a:spcPts val="400"/>
+              </a:spcAft>
+              <a:defRPr sz="1100"/>
+            </a:pPr>
+            <a:r>
+              <a:t>• Reportes diarios exportables a Excel</a:t>
+            </a:r>
+          </a:p>
+          <a:p>
+            <a:pPr>
+              <a:spcAft>
+                <a:spcPts val="400"/>
+              </a:spcAft>
+              <a:defRPr sz="1100"/>
+            </a:pPr>
+            <a:r>
+              <a:t>• Dashboard con resumen de ventas y stock</a:t>
+            </a:r>
+          </a:p>
+          <a:p>
+            <a:pPr>
+              <a:spcAft>
+                <a:spcPts val="400"/>
+              </a:spcAft>
+              <a:defRPr sz="1100"/>
+            </a:pPr>
+            <a:r>
+              <a:t>• Alertas visuales de inventario</a:t>
+            </a:r>
+          </a:p>
+          <a:p>
+            <a:pPr>
+              <a:spcAft>
+                <a:spcPts val="400"/>
+              </a:spcAft>
+              <a:defRPr sz="1100"/>
+            </a:pPr>
+            <a:r>
+              <a:t>• Historial de movimientos y ventas</a:t>
+            </a:r>
+          </a:p>
+        </p:txBody>
+      </p:sp>
     </p:spTree>
     <p:extLst>
       <p:ext uri="{BB962C8B-B14F-4D97-AF65-F5344CB8AC3E}">

</xml_diff>

<commit_message>
feat: actualiza Entrada-Procesos-Salidas con contenido de la imagen de referencia
</commit_message>
<xml_diff>
--- a/presentacion/presentar_el_proyecto/Formato para presentar el Proyecto 2025.pptx
+++ b/presentacion/presentar_el_proyecto/Formato para presentar el Proyecto 2025.pptx
@@ -4614,33 +4614,14 @@
           <a:bodyPr rtlCol="0" anchor="ctr"/>
           <a:lstStyle/>
           <a:p>
-            <a:pPr algn="ctr"/>
-            <a:endParaRPr lang="es-VE"/>
-          </a:p>
-          <a:p>
-            <a:pPr>
-              <a:spcAft>
-                <a:spcPts val="800"/>
-              </a:spcAft>
-              <a:defRPr sz="1400" b="1">
-                <a:solidFill>
-                  <a:srgbClr val="000000"/>
-                </a:solidFill>
-              </a:defRPr>
-            </a:pPr>
-            <a:r>
-              <a:t>PROCESOS</a:t>
-            </a:r>
-          </a:p>
-          <a:p>
             <a:pPr>
               <a:spcAft>
                 <a:spcPts val="400"/>
               </a:spcAft>
-              <a:defRPr sz="1100"/>
             </a:pPr>
             <a:r>
-              <a:t>• Control de inventario (entradas, salidas, ajustes)</a:t>
+              <a:rPr sz="1400" b="1"/>
+              <a:t>PROCESOS</a:t>
             </a:r>
           </a:p>
           <a:p>
@@ -4648,10 +4629,10 @@
               <a:spcAft>
                 <a:spcPts val="400"/>
               </a:spcAft>
-              <a:defRPr sz="1100"/>
             </a:pPr>
             <a:r>
-              <a:t>• Gestión de ventas (totales, pagos mixtos VES/USD)</a:t>
+              <a:rPr sz="1100"/>
+              <a:t>• Validar datos ingresados: existencia del producto, inventario suficiente</a:t>
             </a:r>
           </a:p>
           <a:p>
@@ -4659,10 +4640,10 @@
               <a:spcAft>
                 <a:spcPts val="400"/>
               </a:spcAft>
-              <a:defRPr sz="1100"/>
             </a:pPr>
             <a:r>
-              <a:t>• Autenticación con bcrypt</a:t>
+              <a:rPr sz="1100"/>
+              <a:t>• Convertir precio de dólar a bolívares</a:t>
             </a:r>
           </a:p>
           <a:p>
@@ -4670,10 +4651,10 @@
               <a:spcAft>
                 <a:spcPts val="400"/>
               </a:spcAft>
-              <a:defRPr sz="1100"/>
             </a:pPr>
             <a:r>
-              <a:t>• Generación de reportes diarios</a:t>
+              <a:rPr sz="1100"/>
+              <a:t>• Calcular total de venta</a:t>
             </a:r>
           </a:p>
           <a:p>
@@ -4681,10 +4662,10 @@
               <a:spcAft>
                 <a:spcPts val="400"/>
               </a:spcAft>
-              <a:defRPr sz="1100"/>
             </a:pPr>
             <a:r>
-              <a:t>• Consulta automática de tasas BCV</a:t>
+              <a:rPr sz="1100"/>
+              <a:t>• Registrar tipo de pago</a:t>
             </a:r>
           </a:p>
           <a:p>
@@ -4692,10 +4673,32 @@
               <a:spcAft>
                 <a:spcPts val="400"/>
               </a:spcAft>
-              <a:defRPr sz="1100"/>
             </a:pPr>
             <a:r>
-              <a:t>• Alertas de stock bajo</a:t>
+              <a:rPr sz="1100"/>
+              <a:t>• Registrar la tasa BCV utilizada el día de compra</a:t>
+            </a:r>
+          </a:p>
+          <a:p>
+            <a:pPr>
+              <a:spcAft>
+                <a:spcPts val="400"/>
+              </a:spcAft>
+            </a:pPr>
+            <a:r>
+              <a:rPr sz="1100"/>
+              <a:t>• Actualizar inventario</a:t>
+            </a:r>
+          </a:p>
+          <a:p>
+            <a:pPr>
+              <a:spcAft>
+                <a:spcPts val="400"/>
+              </a:spcAft>
+            </a:pPr>
+            <a:r>
+              <a:rPr sz="1100"/>
+              <a:t>• Generar un comprobante</a:t>
             </a:r>
           </a:p>
         </p:txBody>
@@ -4981,7 +4984,7 @@
         <p:spPr>
           <a:xfrm>
             <a:off x="600000" y="2500000"/>
-            <a:ext cx="3200000" cy="1800000"/>
+            <a:ext cx="3200000" cy="2200000"/>
           </a:xfrm>
           <a:prstGeom prst="rect">
             <a:avLst/>
@@ -5001,7 +5004,7 @@
               <a:defRPr sz="1100"/>
             </a:pPr>
             <a:r>
-              <a:t>• Datos de productos (nombre, categoría, precio, stock)</a:t>
+              <a:t>• Ingresar producto</a:t>
             </a:r>
           </a:p>
           <a:p>
@@ -5012,7 +5015,7 @@
               <a:defRPr sz="1100"/>
             </a:pPr>
             <a:r>
-              <a:t>• Registro de ventas (productos, cantidades, pagos)</a:t>
+              <a:t>• Ingresar cantidades</a:t>
             </a:r>
           </a:p>
           <a:p>
@@ -5023,7 +5026,7 @@
               <a:defRPr sz="1100"/>
             </a:pPr>
             <a:r>
-              <a:t>• Credenciales de usuarios</a:t>
+              <a:t>• Ingresar precio</a:t>
             </a:r>
           </a:p>
           <a:p>
@@ -5034,32 +5037,9 @@
               <a:defRPr sz="1100"/>
             </a:pPr>
             <a:r>
-              <a:t>• Tasas de cambio desde BCV</a:t>
-            </a:r>
-          </a:p>
-        </p:txBody>
-      </p:sp>
-      <p:sp>
-        <p:nvSpPr>
-          <p:cNvPr id="13" name="TextBox 12"/>
-          <p:cNvSpPr txBox="1"/>
-          <p:nvPr/>
-        </p:nvSpPr>
-        <p:spPr>
-          <a:xfrm>
-            <a:off x="7900000" y="2500000"/>
-            <a:ext cx="3600000" cy="2000000"/>
-          </a:xfrm>
-          <a:prstGeom prst="rect">
-            <a:avLst/>
-          </a:prstGeom>
-          <a:noFill/>
-        </p:spPr>
-        <p:txBody>
-          <a:bodyPr wrap="square">
-            <a:spAutoFit/>
-          </a:bodyPr>
-          <a:lstStyle/>
+              <a:t>• Ingresar tipos de pago</a:t>
+            </a:r>
+          </a:p>
           <a:p>
             <a:pPr>
               <a:spcAft>
@@ -5068,7 +5048,7 @@
               <a:defRPr sz="1100"/>
             </a:pPr>
             <a:r>
-              <a:t>• Facturas detalladas de venta</a:t>
+              <a:t>• Fecha de compra</a:t>
             </a:r>
           </a:p>
           <a:p>
@@ -5079,9 +5059,32 @@
               <a:defRPr sz="1100"/>
             </a:pPr>
             <a:r>
-              <a:t>• Reportes diarios exportables a Excel</a:t>
-            </a:r>
-          </a:p>
+              <a:t>• Cambios del día (tasa BCV)</a:t>
+            </a:r>
+          </a:p>
+        </p:txBody>
+      </p:sp>
+      <p:sp>
+        <p:nvSpPr>
+          <p:cNvPr id="13" name="TextBox 12"/>
+          <p:cNvSpPr txBox="1"/>
+          <p:nvPr/>
+        </p:nvSpPr>
+        <p:spPr>
+          <a:xfrm>
+            <a:off x="7900000" y="2500000"/>
+            <a:ext cx="3600000" cy="1800000"/>
+          </a:xfrm>
+          <a:prstGeom prst="rect">
+            <a:avLst/>
+          </a:prstGeom>
+          <a:noFill/>
+        </p:spPr>
+        <p:txBody>
+          <a:bodyPr wrap="square">
+            <a:spAutoFit/>
+          </a:bodyPr>
+          <a:lstStyle/>
           <a:p>
             <a:pPr>
               <a:spcAft>
@@ -5090,7 +5093,7 @@
               <a:defRPr sz="1100"/>
             </a:pPr>
             <a:r>
-              <a:t>• Dashboard con resumen de ventas y stock</a:t>
+              <a:t>• Comprobante de la venta: nombre de productos comprados, precio del día (BCV), tipo de pago, tasa aplicada, fecha y hora</a:t>
             </a:r>
           </a:p>
           <a:p>
@@ -5101,7 +5104,7 @@
               <a:defRPr sz="1100"/>
             </a:pPr>
             <a:r>
-              <a:t>• Alertas visuales de inventario</a:t>
+              <a:t>• Inventarios actualizados</a:t>
             </a:r>
           </a:p>
           <a:p>
@@ -5112,7 +5115,7 @@
               <a:defRPr sz="1100"/>
             </a:pPr>
             <a:r>
-              <a:t>• Historial de movimientos y ventas</a:t>
+              <a:t>• Reportes diarios</a:t>
             </a:r>
           </a:p>
         </p:txBody>

</xml_diff>

<commit_message>
feat: actualiza Entrada-Procesos-Salidas con todas las features del programa
</commit_message>
<xml_diff>
--- a/presentacion/presentar_el_proyecto/Formato para presentar el Proyecto 2025.pptx
+++ b/presentacion/presentar_el_proyecto/Formato para presentar el Proyecto 2025.pptx
@@ -4614,91 +4614,141 @@
           <a:bodyPr rtlCol="0" anchor="ctr"/>
           <a:lstStyle/>
           <a:p>
+            <a:r>
+              <a:rPr sz="1400" b="1"/>
+              <a:t>PROCESOS</a:t>
+            </a:r>
+          </a:p>
+          <a:p>
             <a:pPr>
               <a:spcAft>
-                <a:spcPts val="400"/>
+                <a:spcPts val="200"/>
               </a:spcAft>
             </a:pPr>
             <a:r>
-              <a:rPr sz="1400" b="1"/>
-              <a:t>PROCESOS</a:t>
+              <a:rPr sz="1000"/>
+              <a:t>• Validar existencia del producto e inventario suficiente</a:t>
             </a:r>
           </a:p>
           <a:p>
             <a:pPr>
               <a:spcAft>
-                <a:spcPts val="400"/>
+                <a:spcPts val="200"/>
               </a:spcAft>
             </a:pPr>
             <a:r>
-              <a:rPr sz="1100"/>
-              <a:t>• Validar datos ingresados: existencia del producto, inventario suficiente</a:t>
+              <a:rPr sz="1000"/>
+              <a:t>• Convertir precio USD a bolívares (tasa BCV)</a:t>
             </a:r>
           </a:p>
           <a:p>
             <a:pPr>
               <a:spcAft>
-                <a:spcPts val="400"/>
+                <a:spcPts val="200"/>
               </a:spcAft>
             </a:pPr>
             <a:r>
-              <a:rPr sz="1100"/>
-              <a:t>• Convertir precio de dólar a bolívares</a:t>
+              <a:rPr sz="1000"/>
+              <a:t>• Calcular total de venta (subtotales + total)</a:t>
             </a:r>
           </a:p>
           <a:p>
             <a:pPr>
               <a:spcAft>
-                <a:spcPts val="400"/>
+                <a:spcPts val="200"/>
               </a:spcAft>
             </a:pPr>
             <a:r>
-              <a:rPr sz="1100"/>
-              <a:t>• Calcular total de venta</a:t>
+              <a:rPr sz="1000"/>
+              <a:t>• Registrar tipo de pago (5 métodos, pagos mixtos VES/USD)</a:t>
             </a:r>
           </a:p>
           <a:p>
             <a:pPr>
               <a:spcAft>
-                <a:spcPts val="400"/>
+                <a:spcPts val="200"/>
               </a:spcAft>
             </a:pPr>
             <a:r>
-              <a:rPr sz="1100"/>
-              <a:t>• Registrar tipo de pago</a:t>
+              <a:rPr sz="1000"/>
+              <a:t>• Registrar tasa BCV aplicada en la venta</a:t>
             </a:r>
           </a:p>
           <a:p>
             <a:pPr>
               <a:spcAft>
-                <a:spcPts val="400"/>
+                <a:spcPts val="200"/>
               </a:spcAft>
             </a:pPr>
             <a:r>
-              <a:rPr sz="1100"/>
-              <a:t>• Registrar la tasa BCV utilizada el día de compra</a:t>
+              <a:rPr sz="1000"/>
+              <a:t>• Actualizar inventario con auditoría de movimientos</a:t>
             </a:r>
           </a:p>
           <a:p>
             <a:pPr>
               <a:spcAft>
-                <a:spcPts val="400"/>
+                <a:spcPts val="200"/>
               </a:spcAft>
             </a:pPr>
             <a:r>
-              <a:rPr sz="1100"/>
-              <a:t>• Actualizar inventario</a:t>
+              <a:rPr sz="1000"/>
+              <a:t>• Generar factura (FAC-YYYYMMDD-NNN)</a:t>
             </a:r>
           </a:p>
           <a:p>
             <a:pPr>
               <a:spcAft>
-                <a:spcPts val="400"/>
+                <a:spcPts val="200"/>
               </a:spcAft>
             </a:pPr>
             <a:r>
-              <a:rPr sz="1100"/>
-              <a:t>• Generar un comprobante</a:t>
+              <a:rPr sz="1000"/>
+              <a:t>• Autenticar usuarios con bcrypt</a:t>
+            </a:r>
+          </a:p>
+          <a:p>
+            <a:pPr>
+              <a:spcAft>
+                <a:spcPts val="200"/>
+              </a:spcAft>
+            </a:pPr>
+            <a:r>
+              <a:rPr sz="1000"/>
+              <a:t>• CRUD completo de productos (crear, editar, eliminar)</a:t>
+            </a:r>
+          </a:p>
+          <a:p>
+            <a:pPr>
+              <a:spcAft>
+                <a:spcPts val="200"/>
+              </a:spcAft>
+            </a:pPr>
+            <a:r>
+              <a:rPr sz="1000"/>
+              <a:t>• Control de inventario (compra, venta, merma, ajuste, devolución)</a:t>
+            </a:r>
+          </a:p>
+          <a:p>
+            <a:pPr>
+              <a:spcAft>
+                <a:spcPts val="200"/>
+              </a:spcAft>
+            </a:pPr>
+            <a:r>
+              <a:rPr sz="1000"/>
+              <a:t>• Generar reporte diario consolidado</a:t>
+            </a:r>
+          </a:p>
+          <a:p>
+            <a:pPr>
+              <a:spcAft>
+                <a:spcPts val="200"/>
+              </a:spcAft>
+            </a:pPr>
+            <a:r>
+              <a:rPr sz="1000"/>
+              <a:t>• Exportar reporte a Excel</a:t>
             </a:r>
           </a:p>
         </p:txBody>
@@ -4983,8 +5033,8 @@
         </p:nvSpPr>
         <p:spPr>
           <a:xfrm>
-            <a:off x="600000" y="2500000"/>
-            <a:ext cx="3200000" cy="2200000"/>
+            <a:off x="500000" y="2500000"/>
+            <a:ext cx="3400000" cy="2800000"/>
           </a:xfrm>
           <a:prstGeom prst="rect">
             <a:avLst/>
@@ -4999,67 +5049,89 @@
           <a:p>
             <a:pPr>
               <a:spcAft>
-                <a:spcPts val="400"/>
+                <a:spcPts val="200"/>
               </a:spcAft>
-              <a:defRPr sz="1100"/>
+              <a:defRPr sz="1000"/>
             </a:pPr>
             <a:r>
-              <a:t>• Ingresar producto</a:t>
+              <a:t>• Ingresar producto (nombre, categoría, precio, stock mínimo)</a:t>
             </a:r>
           </a:p>
           <a:p>
             <a:pPr>
               <a:spcAft>
-                <a:spcPts val="400"/>
+                <a:spcPts val="200"/>
               </a:spcAft>
-              <a:defRPr sz="1100"/>
+              <a:defRPr sz="1000"/>
             </a:pPr>
             <a:r>
-              <a:t>• Ingresar cantidades</a:t>
+              <a:t>• Ingresar cantidades (stock inicial, movimientos)</a:t>
             </a:r>
           </a:p>
           <a:p>
             <a:pPr>
               <a:spcAft>
-                <a:spcPts val="400"/>
+                <a:spcPts val="200"/>
               </a:spcAft>
-              <a:defRPr sz="1100"/>
+              <a:defRPr sz="1000"/>
             </a:pPr>
             <a:r>
-              <a:t>• Ingresar precio</a:t>
+              <a:t>• Ingresar precio (VES o USD)</a:t>
             </a:r>
           </a:p>
           <a:p>
             <a:pPr>
               <a:spcAft>
-                <a:spcPts val="400"/>
+                <a:spcPts val="200"/>
               </a:spcAft>
-              <a:defRPr sz="1100"/>
+              <a:defRPr sz="1000"/>
             </a:pPr>
             <a:r>
-              <a:t>• Ingresar tipos de pago</a:t>
+              <a:t>• Ingresar tipos de pago (efectivo BS/USD, pago móvil, tarjeta, bio-pago)</a:t>
             </a:r>
           </a:p>
           <a:p>
             <a:pPr>
               <a:spcAft>
-                <a:spcPts val="400"/>
+                <a:spcPts val="200"/>
               </a:spcAft>
-              <a:defRPr sz="1100"/>
+              <a:defRPr sz="1000"/>
             </a:pPr>
             <a:r>
-              <a:t>• Fecha de compra</a:t>
+              <a:t>• Registrar usuarios (credenciales)</a:t>
             </a:r>
           </a:p>
           <a:p>
             <a:pPr>
               <a:spcAft>
-                <a:spcPts val="400"/>
+                <a:spcPts val="200"/>
               </a:spcAft>
-              <a:defRPr sz="1100"/>
+              <a:defRPr sz="1000"/>
             </a:pPr>
             <a:r>
-              <a:t>• Cambios del día (tasa BCV)</a:t>
+              <a:t>• Fecha de compra/venta</a:t>
+            </a:r>
+          </a:p>
+          <a:p>
+            <a:pPr>
+              <a:spcAft>
+                <a:spcPts val="200"/>
+              </a:spcAft>
+              <a:defRPr sz="1000"/>
+            </a:pPr>
+            <a:r>
+              <a:t>• Cambios del día (tasa BCV automática)</a:t>
+            </a:r>
+          </a:p>
+          <a:p>
+            <a:pPr>
+              <a:spcAft>
+                <a:spcPts val="200"/>
+              </a:spcAft>
+              <a:defRPr sz="1000"/>
+            </a:pPr>
+            <a:r>
+              <a:t>• Movimientos de inventario (compras, ajustes, mermas, devoluciones)</a:t>
             </a:r>
           </a:p>
         </p:txBody>
@@ -5073,7 +5145,7 @@
         <p:spPr>
           <a:xfrm>
             <a:off x="7900000" y="2500000"/>
-            <a:ext cx="3600000" cy="1800000"/>
+            <a:ext cx="3800000" cy="3000000"/>
           </a:xfrm>
           <a:prstGeom prst="rect">
             <a:avLst/>
@@ -5088,34 +5160,100 @@
           <a:p>
             <a:pPr>
               <a:spcAft>
-                <a:spcPts val="400"/>
+                <a:spcPts val="200"/>
               </a:spcAft>
-              <a:defRPr sz="1100"/>
+              <a:defRPr sz="1000"/>
             </a:pPr>
             <a:r>
-              <a:t>• Comprobante de la venta: nombre de productos comprados, precio del día (BCV), tipo de pago, tasa aplicada, fecha y hora</a:t>
+              <a:t>• Comprobante de venta: productos, precio BCV, tipo de pago, tasa aplicada, fecha/hora</a:t>
             </a:r>
           </a:p>
           <a:p>
             <a:pPr>
               <a:spcAft>
-                <a:spcPts val="400"/>
+                <a:spcPts val="200"/>
               </a:spcAft>
-              <a:defRPr sz="1100"/>
+              <a:defRPr sz="1000"/>
             </a:pPr>
             <a:r>
-              <a:t>• Inventarios actualizados</a:t>
+              <a:t>• Factura detallada con formato FAC-YYYYMMDD-NNN</a:t>
             </a:r>
           </a:p>
           <a:p>
             <a:pPr>
               <a:spcAft>
-                <a:spcPts val="400"/>
+                <a:spcPts val="200"/>
               </a:spcAft>
-              <a:defRPr sz="1100"/>
+              <a:defRPr sz="1000"/>
             </a:pPr>
             <a:r>
-              <a:t>• Reportes diarios</a:t>
+              <a:t>• Inventarios actualizados por producto</a:t>
+            </a:r>
+          </a:p>
+          <a:p>
+            <a:pPr>
+              <a:spcAft>
+                <a:spcPts val="200"/>
+              </a:spcAft>
+              <a:defRPr sz="1000"/>
+            </a:pPr>
+            <a:r>
+              <a:t>• Reportes diarios consolidados (ventas, movimientos, tasas)</a:t>
+            </a:r>
+          </a:p>
+          <a:p>
+            <a:pPr>
+              <a:spcAft>
+                <a:spcPts val="200"/>
+              </a:spcAft>
+              <a:defRPr sz="1000"/>
+            </a:pPr>
+            <a:r>
+              <a:t>• Reporte exportable a Excel</a:t>
+            </a:r>
+          </a:p>
+          <a:p>
+            <a:pPr>
+              <a:spcAft>
+                <a:spcPts val="200"/>
+              </a:spcAft>
+              <a:defRPr sz="1000"/>
+            </a:pPr>
+            <a:r>
+              <a:t>• Dashboard: ventas hoy, stock bajo, sin stock, tasa BCV</a:t>
+            </a:r>
+          </a:p>
+          <a:p>
+            <a:pPr>
+              <a:spcAft>
+                <a:spcPts val="200"/>
+              </a:spcAft>
+              <a:defRPr sz="1000"/>
+            </a:pPr>
+            <a:r>
+              <a:t>• Tabla de productos con alerta de stock bajo</a:t>
+            </a:r>
+          </a:p>
+          <a:p>
+            <a:pPr>
+              <a:spcAft>
+                <a:spcPts val="200"/>
+              </a:spcAft>
+              <a:defRPr sz="1000"/>
+            </a:pPr>
+            <a:r>
+              <a:t>• Historial completo de ventas</a:t>
+            </a:r>
+          </a:p>
+          <a:p>
+            <a:pPr>
+              <a:spcAft>
+                <a:spcPts val="200"/>
+              </a:spcAft>
+              <a:defRPr sz="1000"/>
+            </a:pPr>
+            <a:r>
+              <a:t>• Alertas visuales de stock bajo / sin stock</a:t>
             </a:r>
           </a:p>
         </p:txBody>

</xml_diff>